<commit_message>
feat: update full final backend code
</commit_message>
<xml_diff>
--- a/backend/src/public/exports/briefing-session_default.pptx
+++ b/backend/src/public/exports/briefing-session_default.pptx
@@ -1239,7 +1239,7 @@
         </p:nvSpPr>
         <p:spPr>
           <a:xfrm>
-            <a:off x="457200" y="1645920"/>
+            <a:off x="457200" y="1371600"/>
             <a:ext cx="8229600" cy="914400"/>
           </a:xfrm>
           <a:prstGeom prst="rect">
@@ -1275,8 +1275,8 @@
         </p:nvSpPr>
         <p:spPr>
           <a:xfrm>
-            <a:off x="457200" y="2743200"/>
-            <a:ext cx="8229600" cy="731520"/>
+            <a:off x="457200" y="2468880"/>
+            <a:ext cx="8229600" cy="1371600"/>
           </a:xfrm>
           <a:prstGeom prst="rect">
             <a:avLst/>
@@ -1292,28 +1292,42 @@
               <a:buNone/>
             </a:pPr>
             <a:r>
-              <a:rPr lang="en-US" sz="1500" dirty="0">
+              <a:rPr lang="en-US" sz="1400" dirty="0">
                 <a:solidFill>
                   <a:srgbClr val="E2E8F0"/>
                 </a:solidFill>
               </a:rPr>
               <a:t>Multi-Agent Pipeline Audit Outcomes</a:t>
             </a:r>
-            <a:endParaRPr lang="en-US" sz="1500" dirty="0"/>
+            <a:endParaRPr lang="en-US" sz="1400" dirty="0"/>
           </a:p>
           <a:p>
             <a:pPr algn="l" indent="0" marL="0">
               <a:buNone/>
             </a:pPr>
             <a:r>
-              <a:rPr lang="en-US" sz="1500" dirty="0">
+              <a:rPr lang="en-US" sz="1400" dirty="0">
                 <a:solidFill>
                   <a:srgbClr val="E2E8F0"/>
                 </a:solidFill>
               </a:rPr>
               <a:t>Score: 100/100 | Status: FULLY COMPLIANT</a:t>
             </a:r>
-            <a:endParaRPr lang="en-US" sz="1500" dirty="0"/>
+            <a:endParaRPr lang="en-US" sz="1400" dirty="0"/>
+          </a:p>
+          <a:p>
+            <a:pPr algn="l" indent="0" marL="0">
+              <a:buNone/>
+            </a:pPr>
+            <a:r>
+              <a:rPr lang="en-US" sz="1400" dirty="0">
+                <a:solidFill>
+                  <a:srgbClr val="E2E8F0"/>
+                </a:solidFill>
+              </a:rPr>
+              <a:t>Style: Standard Professional Audit Layout | Focus: General AI System</a:t>
+            </a:r>
+            <a:endParaRPr lang="en-US" sz="1400" dirty="0"/>
           </a:p>
         </p:txBody>
       </p:sp>
@@ -1347,7 +1361,7 @@
                   <a:srgbClr val="CBD5E0"/>
                 </a:solidFill>
               </a:rPr>
-              <a:t>Assessed on: 23/05/2026 | Session: session_default</a:t>
+              <a:t>Assessed on: 24/05/2026 | Session: session_default | Strictness: STANDARD</a:t>
             </a:r>
             <a:endParaRPr lang="en-US" sz="1100" dirty="0"/>
           </a:p>
@@ -1467,7 +1481,7 @@
                   <a:srgbClr val="2D3748"/>
                 </a:solidFill>
               </a:rPr>
-              <a:t>• Purpose: autonomous medical diagnostics platform</a:t>
+              <a:t>• Purpose: predict engine failure in advance to prevent unexpected disruption</a:t>
             </a:r>
             <a:endParaRPr lang="en-US" sz="1200" dirty="0"/>
           </a:p>
@@ -1484,7 +1498,7 @@
                   <a:srgbClr val="2D3748"/>
                 </a:solidFill>
               </a:rPr>
-              <a:t>• Sector: Healthcare / High-risk medical diagnostics</a:t>
+              <a:t>• Sector: Manufacturing</a:t>
             </a:r>
             <a:endParaRPr lang="en-US" sz="1200" dirty="0"/>
           </a:p>
@@ -1501,7 +1515,7 @@
                   <a:srgbClr val="2D3748"/>
                 </a:solidFill>
               </a:rPr>
-              <a:t>• Targeted End-Users: Clinical radiologists and hospital staff</a:t>
+              <a:t>• Targeted End-Users: Mosaic</a:t>
             </a:r>
             <a:endParaRPr lang="en-US" sz="1200" dirty="0"/>
           </a:p>
@@ -1518,7 +1532,7 @@
                   <a:srgbClr val="2D3748"/>
                 </a:solidFill>
               </a:rPr>
-              <a:t>• Affected Persons: Patients undergoing diagnostic scanning</a:t>
+              <a:t>• Affected Persons: engine operators, maintenance personnel</a:t>
             </a:r>
             <a:endParaRPr lang="en-US" sz="1200" dirty="0"/>
           </a:p>
@@ -1535,7 +1549,7 @@
                   <a:srgbClr val="2D3748"/>
                 </a:solidFill>
               </a:rPr>
-              <a:t>• Deployment Context: Installed on hospital networks as an integrated clinical decision support tool.</a:t>
+              <a:t>• Deployment Context: Industrial equipment manufacturing</a:t>
             </a:r>
             <a:endParaRPr lang="en-US" sz="1200" dirty="0"/>
           </a:p>
@@ -1552,7 +1566,7 @@
                   <a:srgbClr val="2D3748"/>
                 </a:solidFill>
               </a:rPr>
-              <a:t>• Human Oversight Claims: Clinical radiologists review, sign-off on every output, and can override any AI recommendation with an override button.</a:t>
+              <a:t>• Human Oversight Claims: human oversight is required for accurate and consistent training labels</a:t>
             </a:r>
             <a:endParaRPr lang="en-US" sz="1200" dirty="0"/>
           </a:p>
@@ -1705,7 +1719,7 @@
                   <a:srgbClr val="9B2C2C"/>
                 </a:solidFill>
               </a:rPr>
-              <a:t>High-Risk AI System (Article 6.1 - Annex I Safety Component/Medical Device)</a:t>
+              <a:t>MINIMAL RISK</a:t>
             </a:r>
             <a:endParaRPr lang="en-US" sz="1300" dirty="0"/>
           </a:p>
@@ -1780,7 +1794,7 @@
                   <a:srgbClr val="4A5568"/>
                 </a:solidFill>
               </a:rPr>
-              <a:t>- Article 2 (Scope &amp; Exclusions check - Determines if the system's deployment affects the EU market)</a:t>
+              <a:t>• Article 2 (Scope &amp; Exclusions)</a:t>
             </a:r>
             <a:endParaRPr lang="en-US" sz="1000" dirty="0"/>
           </a:p>
@@ -1797,7 +1811,7 @@
                   <a:srgbClr val="4A5568"/>
                 </a:solidFill>
               </a:rPr>
-              <a:t>- Article 6.1 (High-Risk - Systems linked to Annex I safety components undergoing third-party checks)</a:t>
+              <a:t>• Article 5 (Prohibited AI Systems check)</a:t>
             </a:r>
             <a:endParaRPr lang="en-US" sz="1000" dirty="0"/>
           </a:p>
@@ -1814,7 +1828,7 @@
                   <a:srgbClr val="4A5568"/>
                 </a:solidFill>
               </a:rPr>
-              <a:t>- Articles 9-15 (High-Risk Requirements - Risk management, data governance, technical file, logging, human oversight)</a:t>
+              <a:t>• Article 6 (High-Risk Classification rules)</a:t>
             </a:r>
             <a:endParaRPr lang="en-US" sz="1000" dirty="0"/>
           </a:p>
@@ -1831,7 +1845,7 @@
                   <a:srgbClr val="4A5568"/>
                 </a:solidFill>
               </a:rPr>
-              <a:t>- Article 26 (Deployer Obligations - Controls, monitoring, human oversight compliance for AI deployers)</a:t>
+              <a:t>• Article 26 (Deployer Obligations)</a:t>
             </a:r>
             <a:endParaRPr lang="en-US" sz="1000" dirty="0"/>
           </a:p>
@@ -1848,58 +1862,7 @@
                   <a:srgbClr val="4A5568"/>
                 </a:solidFill>
               </a:rPr>
-              <a:t>- Article 99.4e (Fines - Specific penalty framework for Deployer non-compliance)</a:t>
-            </a:r>
-            <a:endParaRPr lang="en-US" sz="1000" dirty="0"/>
-          </a:p>
-          <a:p>
-            <a:pPr indent="0" marL="0">
-              <a:lnSpc>
-                <a:spcPts val="1600"/>
-              </a:lnSpc>
-              <a:buNone/>
-            </a:pPr>
-            <a:r>
-              <a:rPr lang="en-US" sz="1000" dirty="0">
-                <a:solidFill>
-                  <a:srgbClr val="4A5568"/>
-                </a:solidFill>
-              </a:rPr>
-              <a:t>- Chapter IX (Post-Market Surveillance - Conformance framework for monitoring, info sharing, and market oversight)</a:t>
-            </a:r>
-            <a:endParaRPr lang="en-US" sz="1000" dirty="0"/>
-          </a:p>
-          <a:p>
-            <a:pPr indent="0" marL="0">
-              <a:lnSpc>
-                <a:spcPts val="1600"/>
-              </a:lnSpc>
-              <a:buNone/>
-            </a:pPr>
-            <a:r>
-              <a:rPr lang="en-US" sz="1000" dirty="0">
-                <a:solidFill>
-                  <a:srgbClr val="4A5568"/>
-                </a:solidFill>
-              </a:rPr>
-              <a:t>- Article 99 (General Penalties and Fines framework - Outlines overall administrative enforcement)</a:t>
-            </a:r>
-            <a:endParaRPr lang="en-US" sz="1000" dirty="0"/>
-          </a:p>
-          <a:p>
-            <a:pPr indent="0" marL="0">
-              <a:lnSpc>
-                <a:spcPts val="1600"/>
-              </a:lnSpc>
-              <a:buNone/>
-            </a:pPr>
-            <a:r>
-              <a:rPr lang="en-US" sz="1000" dirty="0">
-                <a:solidFill>
-                  <a:srgbClr val="4A5568"/>
-                </a:solidFill>
-              </a:rPr>
-              <a:t>- EU Legal Supremacy Disclaimer (The AI Act operates alongside, and does not replace, other sectoral EU laws)</a:t>
+              <a:t>• Chapter IX (Post-Market Compliance)</a:t>
             </a:r>
             <a:endParaRPr lang="en-US" sz="1000" dirty="0"/>
           </a:p>
@@ -2019,7 +1982,7 @@
                   <a:srgbClr val="2D3748"/>
                 </a:solidFill>
               </a:rPr>
-              <a:t>• Human Oversight Framework: Human override button triggers manual lockouts, clinical review board oversees high-risk alerts.</a:t>
+              <a:t>• Human Oversight Framework: Critical manual overrides and clinical review boards verify model outputs as mandated by &lt;i&gt;Article 14&lt;/i&gt; human oversight. Current oversight: human oversight is required for accurate and consistent training labels. Verbatim evidence: 'Verbatim evidence retrieved from source document.'. Strict overrides are established for hour-to-hour predictions automation levels.</a:t>
             </a:r>
             <a:endParaRPr lang="en-US" sz="1100" dirty="0"/>
           </a:p>
@@ -2036,7 +1999,7 @@
                   <a:srgbClr val="2D3748"/>
                 </a:solidFill>
               </a:rPr>
-              <a:t>• Technical Documentation: Full system logs, technical file architectures, and operating guidelines are provided.</a:t>
+              <a:t>• Technical Documentation: Technical documentation files compiled for predict engine failure in advance to prevent unexpected disruption (Sector: Manufacturing) under MINIMAL RISK standards pursuant to &lt;i&gt;Article 11&lt;/i&gt;. Supported by explicit evidence: 'Verbatim evidence retrieved from source document.'. Ingests: pressure and temperature differentials between specific components of the engine.</a:t>
             </a:r>
             <a:endParaRPr lang="en-US" sz="1100" dirty="0"/>
           </a:p>
@@ -2053,7 +2016,7 @@
                   <a:srgbClr val="2D3748"/>
                 </a:solidFill>
               </a:rPr>
-              <a:t>• Transparency &amp; Disclosures: Clear user-instructions manual, system capability bounds disclosed in product footer. </a:t>
+              <a:t>• Transparency &amp; Disclosures: Automated disclosure footers warn users of AI-generated content (Predictions of engine failure and type of failure) pursuant to transparency requirements in &lt;i&gt;Article 52&lt;/i&gt;. Operating manuals outline scope for Mosaic per &lt;i&gt;Article 13&lt;/i&gt;.</a:t>
             </a:r>
             <a:endParaRPr lang="en-US" sz="1100" dirty="0"/>
           </a:p>
@@ -2070,7 +2033,7 @@
                   <a:srgbClr val="2D3748"/>
                 </a:solidFill>
               </a:rPr>
-              <a:t>• Lifecycle Logging &amp; Traceability: Automated append-only logging of inputs, inferences, and human overrides.</a:t>
+              <a:t>• Lifecycle Logging &amp; Traceability: Automatic append-only event logs capture inputs (pressure and temperature differentials between specific components of the engine), inference outputs (predictions of engine failure, with a distinction between different failure modes), and manual clinical overrides pursuant to &lt;i&gt;Article 12&lt;/i&gt; record-keeping.</a:t>
             </a:r>
             <a:endParaRPr lang="en-US" sz="1100" dirty="0"/>
           </a:p>
@@ -2087,7 +2050,7 @@
                   <a:srgbClr val="2D3748"/>
                 </a:solidFill>
               </a:rPr>
-              <a:t>• Continuous Monitoring: Continuous telemetry monitor registers sensor drifts and model accuracy.</a:t>
+              <a:t>• Continuous Monitoring: Active telemetry monitors and registers scanner/data drifts and model performance in Industrial equipment manufacturing in compliance with &lt;i&gt;Article 61&lt;/i&gt; post-market monitoring. System checks verify predict engine failure in advance to prevent unexpected disruption bounds.</a:t>
             </a:r>
             <a:endParaRPr lang="en-US" sz="1100" dirty="0"/>
           </a:p>
@@ -2104,7 +2067,7 @@
                   <a:srgbClr val="2D3748"/>
                 </a:solidFill>
               </a:rPr>
-              <a:t>• Accountability structure: Named AI compliance officer assigned; annual external safety audits scheduled.</a:t>
+              <a:t>• Accountability structure: Named regulatory compliance officer assigned to audit predict engine failure in advance to prevent unexpected disruption in Manufacturing in accordance with &lt;i&gt;Article 17&lt;/i&gt; quality management systems. Supported by system audit explanation: Classification is well-supported by the document..</a:t>
             </a:r>
             <a:endParaRPr lang="en-US" sz="1100" dirty="0"/>
           </a:p>
@@ -2221,7 +2184,7 @@
                   <a:srgbClr val="C53030"/>
                 </a:solidFill>
               </a:rPr>
-              <a:t>Audit Findings: Identified 0 Assessment Gaps &amp; 7 Compliance Assumptions.</a:t>
+              <a:t>Audit Findings: Identified 0 Assessment Gaps &amp; 8 Compliance Assumptions.</a:t>
             </a:r>
             <a:endParaRPr lang="en-US" sz="1200" dirty="0"/>
           </a:p>
@@ -2296,7 +2259,7 @@
                   <a:srgbClr val="2D3748"/>
                 </a:solidFill>
               </a:rPr>
-              <a:t>• 1. **Under high-throughput clinical pressures, radiologists are statistically highly susceptible to 'automation bias'. What specific interface controls or confirmation gates prevent clinical sign-off from becoming a passive, rubber-stamped review rather than active ocular verification?**</a:t>
+              <a:t>• 1. **How will the system dynamically identify, version, and log model performance and telemetry deviations when underlying neural network weights or system prompts are updated?**</a:t>
             </a:r>
             <a:endParaRPr lang="en-US" sz="1100" dirty="0"/>
           </a:p>
@@ -2313,24 +2276,7 @@
                   <a:srgbClr val="2D3748"/>
                 </a:solidFill>
               </a:rPr>
-              <a:t>• 2. **Since medical computer vision model performance degrades significantly on scanner variations and calibration drift (e.g., Siemens vs. GE scanner raw outputs), what real-time drift-detection telemetry is implemented to flag accuracy drops before diagnostic anomalies occur?**</a:t>
-            </a:r>
-            <a:endParaRPr lang="en-US" sz="1100" dirty="0"/>
-          </a:p>
-          <a:p>
-            <a:pPr indent="0" marL="0">
-              <a:lnSpc>
-                <a:spcPts val="1800"/>
-              </a:lnSpc>
-              <a:buNone/>
-            </a:pPr>
-            <a:r>
-              <a:rPr lang="en-US" sz="1100" dirty="0">
-                <a:solidFill>
-                  <a:srgbClr val="2D3748"/>
-                </a:solidFill>
-              </a:rPr>
-              <a:t>• 3. **Given that diagnostic reports and anatomical overlays process highly protected healthcare and health-category data under EU definitions, what legal and technical measures are deployed at the ingestion layer to guarantee absolute data minimization and GDPR/HIPAA-compliant containment?**</a:t>
+              <a:t>• 2. **What rigorous, quantitative verification benchmarks (e.g., safety, accuracy, robust adversarial testing) will be used to certify the security posture of this AI deployment before launching in live production contexts?**</a:t>
             </a:r>
             <a:endParaRPr lang="en-US" sz="1100" dirty="0"/>
           </a:p>

</xml_diff>